<commit_message>
Stage 8 review fixes: C-013
</commit_message>
<xml_diff>
--- a/output/archive/Archive/Users/mrinalvesi_old_laptop/DMPK/Working/Copy of DMPK_Capabilities_081417.pptx
+++ b/output/archive/Archive/Users/mrinalvesi_old_laptop/DMPK/Working/Copy of DMPK_Capabilities_081417.pptx
@@ -4309,7 +4309,7 @@
               <a:rPr sz="2000">
                 <a:latin typeface="Times New Roman"/>
               </a:rPr>
-              <a:t>Oral and IV PK in rat, single route per compound, three animals per group</a:t>
+              <a:t>Oral or IV PK in rat; the listed scope covers a single route with three animals, and paired-route work requires an agreed scope</a:t>
             </a:r>
           </a:p>
           <a:p>
@@ -5030,7 +5030,7 @@
               <a:rPr sz="2000">
                 <a:latin typeface="Times New Roman"/>
               </a:rPr>
-              <a:t>Independent DMPK and bioanalysis group in Madison since 2003</a:t>
+              <a:t>DMPK and bioanalysis group established in Madison in 2003</a:t>
             </a:r>
           </a:p>
           <a:p>
@@ -6367,7 +6367,7 @@
               <a:rPr sz="2000">
                 <a:latin typeface="Times New Roman"/>
               </a:rPr>
-              <a:t>Plasma and buffer dialysis run in parallel with the same test article set</a:t>
+              <a:t>Test article equilibrated between plasma and buffer compartments separated by a dialysis membrane</a:t>
             </a:r>
           </a:p>
           <a:p>
@@ -6563,7 +6563,7 @@
               <a:rPr sz="2000">
                 <a:latin typeface="Times New Roman"/>
               </a:rPr>
-              <a:t>Monolayer integrity checked on each plate before compounds are added</a:t>
+              <a:t>Monolayer integrity assessed with the transport controls; compromised monolayers are excluded from interpretation</a:t>
             </a:r>
           </a:p>
           <a:p>
@@ -6741,7 +6741,7 @@
               <a:rPr sz="2000">
                 <a:latin typeface="Times New Roman"/>
               </a:rPr>
-              <a:t>Read by UV after filtration; LC-MS confirmation on request</a:t>
+              <a:t>Readout and sample handling specified in the assay protocol; limitations recorded with the result</a:t>
             </a:r>
           </a:p>
           <a:p>

</xml_diff>